<commit_message>
Update the first PPT slide with the full team contributions
</commit_message>
<xml_diff>
--- a/ML PPT.pptx
+++ b/ML PPT.pptx
@@ -14203,7 +14203,7 @@
         <p:spPr>
           <a:xfrm>
             <a:off x="365760" y="1024128"/>
-            <a:ext cx="8412480" cy="1444752"/>
+            <a:ext cx="8412480" cy="1335024"/>
           </a:xfrm>
           <a:prstGeom prst="roundRect">
             <a:avLst>
@@ -14356,7 +14356,7 @@
         </p:nvSpPr>
         <p:spPr>
           <a:xfrm>
-            <a:off x="365760" y="2596896"/>
+            <a:off x="365760" y="2450592"/>
             <a:ext cx="8412480" cy="274320"/>
           </a:xfrm>
           <a:prstGeom prst="rect">
@@ -14407,7 +14407,7 @@
                 <a:cs typeface="Arial"/>
                 <a:sym typeface="Arial"/>
               </a:rPr>
-              <a:t>   all three: joint reproduction of ECERC on IEMOCAP and MELD</a:t>
+              <a:t>   all three: reproducing ECERC and merging the fixes into the final systems</a:t>
             </a:r>
             <a:endParaRPr/>
           </a:p>
@@ -14421,8 +14421,8 @@
         </p:nvSpPr>
         <p:spPr>
           <a:xfrm>
-            <a:off x="365760" y="2926080"/>
-            <a:ext cx="2697480" cy="1965960"/>
+            <a:off x="365760" y="2779776"/>
+            <a:ext cx="2697480" cy="2157984"/>
           </a:xfrm>
           <a:prstGeom prst="roundRect">
             <a:avLst>
@@ -14483,8 +14483,8 @@
         </p:nvSpPr>
         <p:spPr>
           <a:xfrm>
-            <a:off x="493776" y="3017520"/>
-            <a:ext cx="2441448" cy="1801368"/>
+            <a:off x="493776" y="2862072"/>
+            <a:ext cx="2441448" cy="1993392"/>
           </a:xfrm>
           <a:prstGeom prst="rect">
             <a:avLst/>
@@ -14581,7 +14581,7 @@
                 <a:cs typeface="Arial"/>
                 <a:sym typeface="Arial"/>
               </a:rPr>
-              <a:t>Confusion-aware supervised contrastive loss on fused features</a:t>
+              <a:t>Tested 6 methods in a 20-seed paired study</a:t>
             </a:r>
             <a:endParaRPr/>
           </a:p>
@@ -14591,7 +14591,7 @@
                 <a:spcPct val="100000"/>
               </a:lnSpc>
               <a:spcBef>
-                <a:spcPts val="400"/>
+                <a:spcPts val="600"/>
               </a:spcBef>
               <a:spcAft>
                 <a:spcPts val="0"/>
@@ -14613,7 +14613,7 @@
                 <a:cs typeface="Arial"/>
                 <a:sym typeface="Arial"/>
               </a:rPr>
-              <a:t>Pair-confusion penalty for Happy↔Excited and Angry↔Frustrated</a:t>
+              <a:t>Extracted WavLM audio for 7,433 utterances; added VAD supervision</a:t>
             </a:r>
             <a:endParaRPr/>
           </a:p>
@@ -14623,7 +14623,7 @@
                 <a:spcPct val="100000"/>
               </a:lnSpc>
               <a:spcBef>
-                <a:spcPts val="400"/>
+                <a:spcPts val="600"/>
               </a:spcBef>
               <a:spcAft>
                 <a:spcPts val="0"/>
@@ -14645,7 +14645,39 @@
                 <a:cs typeface="Arial"/>
                 <a:sym typeface="Arial"/>
               </a:rPr>
-              <a:t>P4 vs authors: pair errors 180.5 → 174.3 (Hap↔Exc 87.0 → 79.0)</a:t>
+              <a:t>wF1 +1.43; 20% fewer clear Angry↔Frustrated errors</a:t>
+            </a:r>
+            <a:endParaRPr/>
+          </a:p>
+          <a:p>
+            <a:pPr indent="-146304" lvl="0" marL="146304" marR="0" rtl="0" algn="l">
+              <a:lnSpc>
+                <a:spcPct val="100000"/>
+              </a:lnSpc>
+              <a:spcBef>
+                <a:spcPts val="600"/>
+              </a:spcBef>
+              <a:spcAft>
+                <a:spcPts val="0"/>
+              </a:spcAft>
+              <a:buClr>
+                <a:srgbClr val="000000"/>
+              </a:buClr>
+              <a:buSzPts val="1050"/>
+              <a:buFont typeface="Arial"/>
+              <a:buChar char="•"/>
+            </a:pPr>
+            <a:r>
+              <a:rPr b="0" i="0" lang="en" spc="0" sz="1050" u="none" cap="none" strike="noStrike">
+                <a:solidFill>
+                  <a:srgbClr val="262626"/>
+                </a:solidFill>
+                <a:latin typeface="Arial"/>
+                <a:ea typeface="Arial"/>
+                <a:cs typeface="Arial"/>
+                <a:sym typeface="Arial"/>
+              </a:rPr>
+              <a:t>Merged L1 + L3: 72.43 wF1 ensemble; wrote the IEMOCAP report</a:t>
             </a:r>
             <a:endParaRPr/>
           </a:p>
@@ -14659,8 +14691,8 @@
         </p:nvSpPr>
         <p:spPr>
           <a:xfrm>
-            <a:off x="3223260" y="2926080"/>
-            <a:ext cx="2697480" cy="1965960"/>
+            <a:off x="3223260" y="2779776"/>
+            <a:ext cx="2697480" cy="2157984"/>
           </a:xfrm>
           <a:prstGeom prst="roundRect">
             <a:avLst>
@@ -14721,8 +14753,8 @@
         </p:nvSpPr>
         <p:spPr>
           <a:xfrm>
-            <a:off x="3351276" y="3017520"/>
-            <a:ext cx="2441448" cy="1801368"/>
+            <a:off x="3351276" y="2862072"/>
+            <a:ext cx="2441448" cy="1993392"/>
           </a:xfrm>
           <a:prstGeom prst="rect">
             <a:avLst/>
@@ -14819,7 +14851,7 @@
                 <a:cs typeface="Arial"/>
                 <a:sym typeface="Arial"/>
               </a:rPr>
-              <a:t>Class-balanced (effective-number) weights and focal loss γ = 2</a:t>
+              <a:t>Tested 12 methods across loss, sampling, features and trained experts</a:t>
             </a:r>
             <a:endParaRPr/>
           </a:p>
@@ -14829,7 +14861,7 @@
                 <a:spcPct val="100000"/>
               </a:lnSpc>
               <a:spcBef>
-                <a:spcPts val="400"/>
+                <a:spcPts val="600"/>
               </a:spcBef>
               <a:spcAft>
                 <a:spcPts val="0"/>
@@ -14851,7 +14883,7 @@
                 <a:cs typeface="Arial"/>
                 <a:sym typeface="Arial"/>
               </a:rPr>
-              <a:t>Dialogue-level oversampling of Fear and Disgust</a:t>
+              <a:t>Pre-registered zero-shot Qwen2.5-32B LLM fusion: mF1 +3.38</a:t>
             </a:r>
             <a:endParaRPr/>
           </a:p>
@@ -14861,7 +14893,7 @@
                 <a:spcPct val="100000"/>
               </a:lnSpc>
               <a:spcBef>
-                <a:spcPts val="400"/>
+                <a:spcPts val="600"/>
               </a:spcBef>
               <a:spcAft>
                 <a:spcPts val="0"/>
@@ -14883,7 +14915,39 @@
                 <a:cs typeface="Arial"/>
                 <a:sym typeface="Arial"/>
               </a:rPr>
-              <a:t>Controlled 3-seed study, validation-only model selection</a:t>
+              <a:t>Spotted the release's focal γ = 1 loss</a:t>
+            </a:r>
+            <a:endParaRPr/>
+          </a:p>
+          <a:p>
+            <a:pPr indent="-146304" lvl="0" marL="146304" marR="0" rtl="0" algn="l">
+              <a:lnSpc>
+                <a:spcPct val="100000"/>
+              </a:lnSpc>
+              <a:spcBef>
+                <a:spcPts val="600"/>
+              </a:spcBef>
+              <a:spcAft>
+                <a:spcPts val="0"/>
+              </a:spcAft>
+              <a:buClr>
+                <a:srgbClr val="000000"/>
+              </a:buClr>
+              <a:buSzPts val="1050"/>
+              <a:buFont typeface="Arial"/>
+              <a:buChar char="•"/>
+            </a:pPr>
+            <a:r>
+              <a:rPr b="0" i="0" lang="en" spc="0" sz="1050" u="none" cap="none" strike="noStrike">
+                <a:solidFill>
+                  <a:srgbClr val="262626"/>
+                </a:solidFill>
+                <a:latin typeface="Arial"/>
+                <a:ea typeface="Arial"/>
+                <a:cs typeface="Arial"/>
+                <a:sym typeface="Arial"/>
+              </a:rPr>
+              <a:t>Merged L2 + L3: 53.77 mF1, +2.90 over authors; MELD report and figures</a:t>
             </a:r>
             <a:endParaRPr/>
           </a:p>
@@ -14897,8 +14961,8 @@
         </p:nvSpPr>
         <p:spPr>
           <a:xfrm>
-            <a:off x="6080760" y="2926080"/>
-            <a:ext cx="2697480" cy="1965960"/>
+            <a:off x="6080760" y="2779776"/>
+            <a:ext cx="2697480" cy="2157984"/>
           </a:xfrm>
           <a:prstGeom prst="roundRect">
             <a:avLst>
@@ -14959,8 +15023,8 @@
         </p:nvSpPr>
         <p:spPr>
           <a:xfrm>
-            <a:off x="6208776" y="3017520"/>
-            <a:ext cx="2441448" cy="1801368"/>
+            <a:off x="6208776" y="2862072"/>
+            <a:ext cx="2441448" cy="1993392"/>
           </a:xfrm>
           <a:prstGeom prst="rect">
             <a:avLst/>
@@ -15057,7 +15121,7 @@
                 <a:cs typeface="Arial"/>
                 <a:sym typeface="Arial"/>
               </a:rPr>
-              <a:t>CACG: masked cause-level softmax with a per-utterance temperature</a:t>
+              <a:t>Audited and rewrote ECERC as one package; ran 42-run ablation</a:t>
             </a:r>
             <a:endParaRPr/>
           </a:p>
@@ -15067,7 +15131,7 @@
                 <a:spcPct val="100000"/>
               </a:lnSpc>
               <a:spcBef>
-                <a:spcPts val="400"/>
+                <a:spcPts val="600"/>
               </a:spcBef>
               <a:spcAft>
                 <a:spcPts val="0"/>
@@ -15089,7 +15153,7 @@
                 <a:cs typeface="Arial"/>
                 <a:sym typeface="Arial"/>
               </a:rPr>
-              <a:t>Label-grounded utility gate loss; fixed empty-history attention leak</a:t>
+              <a:t>CACG, utility gate loss and per-utterance cause weights</a:t>
             </a:r>
             <a:endParaRPr/>
           </a:p>
@@ -15099,7 +15163,7 @@
                 <a:spcPct val="100000"/>
               </a:lnSpc>
               <a:spcBef>
-                <a:spcPts val="400"/>
+                <a:spcPts val="600"/>
               </a:spcBef>
               <a:spcAft>
                 <a:spcPts val="0"/>
@@ -15121,7 +15185,39 @@
                 <a:cs typeface="Arial"/>
                 <a:sym typeface="Arial"/>
               </a:rPr>
-              <a:t>ECE 13.6 → 2.9 (IEMOCAP), 9.5 → 2.4 (MELD)</a:t>
+              <a:t>Temperature scaling (ECE 14.36 → 3.72), ensembles, low-confidence flag</a:t>
+            </a:r>
+            <a:endParaRPr/>
+          </a:p>
+          <a:p>
+            <a:pPr indent="-146304" lvl="0" marL="146304" marR="0" rtl="0" algn="l">
+              <a:lnSpc>
+                <a:spcPct val="100000"/>
+              </a:lnSpc>
+              <a:spcBef>
+                <a:spcPts val="600"/>
+              </a:spcBef>
+              <a:spcAft>
+                <a:spcPts val="0"/>
+              </a:spcAft>
+              <a:buClr>
+                <a:srgbClr val="000000"/>
+              </a:buClr>
+              <a:buSzPts val="1050"/>
+              <a:buFont typeface="Arial"/>
+              <a:buChar char="•"/>
+            </a:pPr>
+            <a:r>
+              <a:rPr b="0" i="0" lang="en" spc="0" sz="1050" u="none" cap="none" strike="noStrike">
+                <a:solidFill>
+                  <a:srgbClr val="262626"/>
+                </a:solidFill>
+                <a:latin typeface="Arial"/>
+                <a:ea typeface="Arial"/>
+                <a:cs typeface="Arial"/>
+                <a:sym typeface="Arial"/>
+              </a:rPr>
+              <a:t>Merged L1 + L2 + L3: 72.77 wF1, 53.82 mF1; demo, report, diagrams</a:t>
             </a:r>
             <a:endParaRPr/>
           </a:p>

</xml_diff>